<commit_message>
chore: clean up old deck iterations, keep only final PPTX
Remove 7 intermediate PPTX files and the DOCX export, retaining only
the final 1703 deck as the canonical presentation artifact.

Co-Authored-By: Claude Opus 4.6 (1M context) <noreply@anthropic.com>
</commit_message>
<xml_diff>
--- a/docs/presentation/autonomize-ai-pa-solution-architecture-paul-prae-2026-03-25-1703.pptx
+++ b/docs/presentation/autonomize-ai-pa-solution-architecture-paul-prae-2026-03-25-1703.pptx
@@ -5,23 +5,23 @@
     <p:sldMasterId id="2147483648" r:id="rId1"/>
   </p:sldMasterIdLst>
   <p:sldIdLst>
-    <p:sldId id="256" r:id="rId7"/>
-    <p:sldId id="257" r:id="rId8"/>
-    <p:sldId id="258" r:id="rId9"/>
-    <p:sldId id="259" r:id="rId10"/>
-    <p:sldId id="260" r:id="rId11"/>
-    <p:sldId id="261" r:id="rId12"/>
-    <p:sldId id="262" r:id="rId13"/>
-    <p:sldId id="263" r:id="rId14"/>
-    <p:sldId id="264" r:id="rId15"/>
-    <p:sldId id="265" r:id="rId16"/>
-    <p:sldId id="266" r:id="rId17"/>
-    <p:sldId id="267" r:id="rId18"/>
-    <p:sldId id="268" r:id="rId19"/>
-    <p:sldId id="269" r:id="rId20"/>
-    <p:sldId id="270" r:id="rId21"/>
+    <p:sldId id="256" r:id="rId2"/>
+    <p:sldId id="257" r:id="rId3"/>
+    <p:sldId id="258" r:id="rId4"/>
+    <p:sldId id="259" r:id="rId5"/>
+    <p:sldId id="260" r:id="rId6"/>
+    <p:sldId id="261" r:id="rId7"/>
+    <p:sldId id="262" r:id="rId8"/>
+    <p:sldId id="263" r:id="rId9"/>
+    <p:sldId id="264" r:id="rId10"/>
+    <p:sldId id="265" r:id="rId11"/>
+    <p:sldId id="266" r:id="rId12"/>
+    <p:sldId id="267" r:id="rId13"/>
+    <p:sldId id="268" r:id="rId14"/>
+    <p:sldId id="269" r:id="rId15"/>
+    <p:sldId id="270" r:id="rId16"/>
   </p:sldIdLst>
-  <p:sldSz cx="12188952" cy="6858000" type="screen4x3"/>
+  <p:sldSz cx="12188825" cy="6858000"/>
   <p:notesSz cx="6858000" cy="9144000"/>
   <p:defaultTextStyle>
     <a:defPPr>
@@ -118,6 +118,22 @@
       </a:defRPr>
     </a:lvl9pPr>
   </p:defaultTextStyle>
+  <p:extLst>
+    <p:ext uri="{EFAFB233-063F-42B5-8137-9DF3F51BA10A}">
+      <p15:sldGuideLst xmlns:p15="http://schemas.microsoft.com/office/powerpoint/2012/main">
+        <p15:guide id="1" orient="horz" pos="2160">
+          <p15:clr>
+            <a:srgbClr val="A4A3A4"/>
+          </p15:clr>
+        </p15:guide>
+        <p15:guide id="2" pos="2880">
+          <p15:clr>
+            <a:srgbClr val="A4A3A4"/>
+          </p15:clr>
+        </p15:guide>
+      </p15:sldGuideLst>
+    </p:ext>
+  </p:extLst>
 </p:presentation>
 </file>
 
@@ -159,10 +175,9 @@
           <a:lstStyle/>
           <a:p>
             <a:r>
-              <a:rPr lang="en-US" smtClean="0"/>
+              <a:rPr lang="en-US"/>
               <a:t>Click to edit Master title style</a:t>
             </a:r>
-            <a:endParaRPr lang="en-US"/>
           </a:p>
         </p:txBody>
       </p:sp>
@@ -278,10 +293,9 @@
           </a:lstStyle>
           <a:p>
             <a:r>
-              <a:rPr lang="en-US" smtClean="0"/>
+              <a:rPr lang="en-US"/>
               <a:t>Click to edit Master subtitle style</a:t>
             </a:r>
-            <a:endParaRPr lang="en-US"/>
           </a:p>
         </p:txBody>
       </p:sp>
@@ -302,7 +316,7 @@
           <a:p>
             <a:fld id="{5BCAD085-E8A6-8845-BD4E-CB4CCA059FC4}" type="datetimeFigureOut">
               <a:rPr lang="en-US" smtClean="0"/>
-              <a:t>1/27/13</a:t>
+              <a:t>3/25/2026</a:t>
             </a:fld>
             <a:endParaRPr lang="en-US"/>
           </a:p>
@@ -396,10 +410,9 @@
           <a:lstStyle/>
           <a:p>
             <a:r>
-              <a:rPr lang="en-US" smtClean="0"/>
+              <a:rPr lang="en-US"/>
               <a:t>Click to edit Master title style</a:t>
             </a:r>
-            <a:endParaRPr lang="en-US"/>
           </a:p>
         </p:txBody>
       </p:sp>
@@ -420,38 +433,37 @@
           <a:p>
             <a:pPr lvl="0"/>
             <a:r>
-              <a:rPr lang="en-US" smtClean="0"/>
+              <a:rPr lang="en-US"/>
               <a:t>Click to edit Master text styles</a:t>
             </a:r>
           </a:p>
           <a:p>
             <a:pPr lvl="1"/>
             <a:r>
-              <a:rPr lang="en-US" smtClean="0"/>
+              <a:rPr lang="en-US"/>
               <a:t>Second level</a:t>
             </a:r>
           </a:p>
           <a:p>
             <a:pPr lvl="2"/>
             <a:r>
-              <a:rPr lang="en-US" smtClean="0"/>
+              <a:rPr lang="en-US"/>
               <a:t>Third level</a:t>
             </a:r>
           </a:p>
           <a:p>
             <a:pPr lvl="3"/>
             <a:r>
-              <a:rPr lang="en-US" smtClean="0"/>
+              <a:rPr lang="en-US"/>
               <a:t>Fourth level</a:t>
             </a:r>
           </a:p>
           <a:p>
             <a:pPr lvl="4"/>
             <a:r>
-              <a:rPr lang="en-US" smtClean="0"/>
+              <a:rPr lang="en-US"/>
               <a:t>Fifth level</a:t>
             </a:r>
-            <a:endParaRPr lang="en-US"/>
           </a:p>
         </p:txBody>
       </p:sp>
@@ -472,7 +484,7 @@
           <a:p>
             <a:fld id="{5BCAD085-E8A6-8845-BD4E-CB4CCA059FC4}" type="datetimeFigureOut">
               <a:rPr lang="en-US" smtClean="0"/>
-              <a:t>1/27/13</a:t>
+              <a:t>3/25/2026</a:t>
             </a:fld>
             <a:endParaRPr lang="en-US"/>
           </a:p>
@@ -571,10 +583,9 @@
           <a:lstStyle/>
           <a:p>
             <a:r>
-              <a:rPr lang="en-US" smtClean="0"/>
+              <a:rPr lang="en-US"/>
               <a:t>Click to edit Master title style</a:t>
             </a:r>
-            <a:endParaRPr lang="en-US"/>
           </a:p>
         </p:txBody>
       </p:sp>
@@ -600,38 +611,37 @@
           <a:p>
             <a:pPr lvl="0"/>
             <a:r>
-              <a:rPr lang="en-US" smtClean="0"/>
+              <a:rPr lang="en-US"/>
               <a:t>Click to edit Master text styles</a:t>
             </a:r>
           </a:p>
           <a:p>
             <a:pPr lvl="1"/>
             <a:r>
-              <a:rPr lang="en-US" smtClean="0"/>
+              <a:rPr lang="en-US"/>
               <a:t>Second level</a:t>
             </a:r>
           </a:p>
           <a:p>
             <a:pPr lvl="2"/>
             <a:r>
-              <a:rPr lang="en-US" smtClean="0"/>
+              <a:rPr lang="en-US"/>
               <a:t>Third level</a:t>
             </a:r>
           </a:p>
           <a:p>
             <a:pPr lvl="3"/>
             <a:r>
-              <a:rPr lang="en-US" smtClean="0"/>
+              <a:rPr lang="en-US"/>
               <a:t>Fourth level</a:t>
             </a:r>
           </a:p>
           <a:p>
             <a:pPr lvl="4"/>
             <a:r>
-              <a:rPr lang="en-US" smtClean="0"/>
+              <a:rPr lang="en-US"/>
               <a:t>Fifth level</a:t>
             </a:r>
-            <a:endParaRPr lang="en-US"/>
           </a:p>
         </p:txBody>
       </p:sp>
@@ -652,7 +662,7 @@
           <a:p>
             <a:fld id="{5BCAD085-E8A6-8845-BD4E-CB4CCA059FC4}" type="datetimeFigureOut">
               <a:rPr lang="en-US" smtClean="0"/>
-              <a:t>1/27/13</a:t>
+              <a:t>3/25/2026</a:t>
             </a:fld>
             <a:endParaRPr lang="en-US"/>
           </a:p>
@@ -746,10 +756,9 @@
           <a:lstStyle/>
           <a:p>
             <a:r>
-              <a:rPr lang="en-US" smtClean="0"/>
+              <a:rPr lang="en-US"/>
               <a:t>Click to edit Master title style</a:t>
             </a:r>
-            <a:endParaRPr lang="en-US"/>
           </a:p>
         </p:txBody>
       </p:sp>
@@ -770,38 +779,37 @@
           <a:p>
             <a:pPr lvl="0"/>
             <a:r>
-              <a:rPr lang="en-US" smtClean="0"/>
+              <a:rPr lang="en-US"/>
               <a:t>Click to edit Master text styles</a:t>
             </a:r>
           </a:p>
           <a:p>
             <a:pPr lvl="1"/>
             <a:r>
-              <a:rPr lang="en-US" smtClean="0"/>
+              <a:rPr lang="en-US"/>
               <a:t>Second level</a:t>
             </a:r>
           </a:p>
           <a:p>
             <a:pPr lvl="2"/>
             <a:r>
-              <a:rPr lang="en-US" smtClean="0"/>
+              <a:rPr lang="en-US"/>
               <a:t>Third level</a:t>
             </a:r>
           </a:p>
           <a:p>
             <a:pPr lvl="3"/>
             <a:r>
-              <a:rPr lang="en-US" smtClean="0"/>
+              <a:rPr lang="en-US"/>
               <a:t>Fourth level</a:t>
             </a:r>
           </a:p>
           <a:p>
             <a:pPr lvl="4"/>
             <a:r>
-              <a:rPr lang="en-US" smtClean="0"/>
+              <a:rPr lang="en-US"/>
               <a:t>Fifth level</a:t>
             </a:r>
-            <a:endParaRPr lang="en-US"/>
           </a:p>
         </p:txBody>
       </p:sp>
@@ -822,7 +830,7 @@
           <a:p>
             <a:fld id="{5BCAD085-E8A6-8845-BD4E-CB4CCA059FC4}" type="datetimeFigureOut">
               <a:rPr lang="en-US" smtClean="0"/>
-              <a:t>1/27/13</a:t>
+              <a:t>3/25/2026</a:t>
             </a:fld>
             <a:endParaRPr lang="en-US"/>
           </a:p>
@@ -925,10 +933,9 @@
           </a:lstStyle>
           <a:p>
             <a:r>
-              <a:rPr lang="en-US" smtClean="0"/>
+              <a:rPr lang="en-US"/>
               <a:t>Click to edit Master title style</a:t>
             </a:r>
-            <a:endParaRPr lang="en-US"/>
           </a:p>
         </p:txBody>
       </p:sp>
@@ -1045,7 +1052,7 @@
           <a:p>
             <a:pPr lvl="0"/>
             <a:r>
-              <a:rPr lang="en-US" smtClean="0"/>
+              <a:rPr lang="en-US"/>
               <a:t>Click to edit Master text styles</a:t>
             </a:r>
           </a:p>
@@ -1068,7 +1075,7 @@
           <a:p>
             <a:fld id="{5BCAD085-E8A6-8845-BD4E-CB4CCA059FC4}" type="datetimeFigureOut">
               <a:rPr lang="en-US" smtClean="0"/>
-              <a:t>1/27/13</a:t>
+              <a:t>3/25/2026</a:t>
             </a:fld>
             <a:endParaRPr lang="en-US"/>
           </a:p>
@@ -1162,10 +1169,9 @@
           <a:lstStyle/>
           <a:p>
             <a:r>
-              <a:rPr lang="en-US" smtClean="0"/>
+              <a:rPr lang="en-US"/>
               <a:t>Click to edit Master title style</a:t>
             </a:r>
-            <a:endParaRPr lang="en-US"/>
           </a:p>
         </p:txBody>
       </p:sp>
@@ -1219,38 +1225,37 @@
           <a:p>
             <a:pPr lvl="0"/>
             <a:r>
-              <a:rPr lang="en-US" smtClean="0"/>
+              <a:rPr lang="en-US"/>
               <a:t>Click to edit Master text styles</a:t>
             </a:r>
           </a:p>
           <a:p>
             <a:pPr lvl="1"/>
             <a:r>
-              <a:rPr lang="en-US" smtClean="0"/>
+              <a:rPr lang="en-US"/>
               <a:t>Second level</a:t>
             </a:r>
           </a:p>
           <a:p>
             <a:pPr lvl="2"/>
             <a:r>
-              <a:rPr lang="en-US" smtClean="0"/>
+              <a:rPr lang="en-US"/>
               <a:t>Third level</a:t>
             </a:r>
           </a:p>
           <a:p>
             <a:pPr lvl="3"/>
             <a:r>
-              <a:rPr lang="en-US" smtClean="0"/>
+              <a:rPr lang="en-US"/>
               <a:t>Fourth level</a:t>
             </a:r>
           </a:p>
           <a:p>
             <a:pPr lvl="4"/>
             <a:r>
-              <a:rPr lang="en-US" smtClean="0"/>
+              <a:rPr lang="en-US"/>
               <a:t>Fifth level</a:t>
             </a:r>
-            <a:endParaRPr lang="en-US"/>
           </a:p>
         </p:txBody>
       </p:sp>
@@ -1304,38 +1309,37 @@
           <a:p>
             <a:pPr lvl="0"/>
             <a:r>
-              <a:rPr lang="en-US" smtClean="0"/>
+              <a:rPr lang="en-US"/>
               <a:t>Click to edit Master text styles</a:t>
             </a:r>
           </a:p>
           <a:p>
             <a:pPr lvl="1"/>
             <a:r>
-              <a:rPr lang="en-US" smtClean="0"/>
+              <a:rPr lang="en-US"/>
               <a:t>Second level</a:t>
             </a:r>
           </a:p>
           <a:p>
             <a:pPr lvl="2"/>
             <a:r>
-              <a:rPr lang="en-US" smtClean="0"/>
+              <a:rPr lang="en-US"/>
               <a:t>Third level</a:t>
             </a:r>
           </a:p>
           <a:p>
             <a:pPr lvl="3"/>
             <a:r>
-              <a:rPr lang="en-US" smtClean="0"/>
+              <a:rPr lang="en-US"/>
               <a:t>Fourth level</a:t>
             </a:r>
           </a:p>
           <a:p>
             <a:pPr lvl="4"/>
             <a:r>
-              <a:rPr lang="en-US" smtClean="0"/>
+              <a:rPr lang="en-US"/>
               <a:t>Fifth level</a:t>
             </a:r>
-            <a:endParaRPr lang="en-US"/>
           </a:p>
         </p:txBody>
       </p:sp>
@@ -1356,7 +1360,7 @@
           <a:p>
             <a:fld id="{5BCAD085-E8A6-8845-BD4E-CB4CCA059FC4}" type="datetimeFigureOut">
               <a:rPr lang="en-US" smtClean="0"/>
-              <a:t>1/27/13</a:t>
+              <a:t>3/25/2026</a:t>
             </a:fld>
             <a:endParaRPr lang="en-US"/>
           </a:p>
@@ -1454,10 +1458,9 @@
           </a:lstStyle>
           <a:p>
             <a:r>
-              <a:rPr lang="en-US" smtClean="0"/>
+              <a:rPr lang="en-US"/>
               <a:t>Click to edit Master title style</a:t>
             </a:r>
-            <a:endParaRPr lang="en-US"/>
           </a:p>
         </p:txBody>
       </p:sp>
@@ -1520,7 +1523,7 @@
           <a:p>
             <a:pPr lvl="0"/>
             <a:r>
-              <a:rPr lang="en-US" smtClean="0"/>
+              <a:rPr lang="en-US"/>
               <a:t>Click to edit Master text styles</a:t>
             </a:r>
           </a:p>
@@ -1576,38 +1579,37 @@
           <a:p>
             <a:pPr lvl="0"/>
             <a:r>
-              <a:rPr lang="en-US" smtClean="0"/>
+              <a:rPr lang="en-US"/>
               <a:t>Click to edit Master text styles</a:t>
             </a:r>
           </a:p>
           <a:p>
             <a:pPr lvl="1"/>
             <a:r>
-              <a:rPr lang="en-US" smtClean="0"/>
+              <a:rPr lang="en-US"/>
               <a:t>Second level</a:t>
             </a:r>
           </a:p>
           <a:p>
             <a:pPr lvl="2"/>
             <a:r>
-              <a:rPr lang="en-US" smtClean="0"/>
+              <a:rPr lang="en-US"/>
               <a:t>Third level</a:t>
             </a:r>
           </a:p>
           <a:p>
             <a:pPr lvl="3"/>
             <a:r>
-              <a:rPr lang="en-US" smtClean="0"/>
+              <a:rPr lang="en-US"/>
               <a:t>Fourth level</a:t>
             </a:r>
           </a:p>
           <a:p>
             <a:pPr lvl="4"/>
             <a:r>
-              <a:rPr lang="en-US" smtClean="0"/>
+              <a:rPr lang="en-US"/>
               <a:t>Fifth level</a:t>
             </a:r>
-            <a:endParaRPr lang="en-US"/>
           </a:p>
         </p:txBody>
       </p:sp>
@@ -1670,7 +1672,7 @@
           <a:p>
             <a:pPr lvl="0"/>
             <a:r>
-              <a:rPr lang="en-US" smtClean="0"/>
+              <a:rPr lang="en-US"/>
               <a:t>Click to edit Master text styles</a:t>
             </a:r>
           </a:p>
@@ -1726,38 +1728,37 @@
           <a:p>
             <a:pPr lvl="0"/>
             <a:r>
-              <a:rPr lang="en-US" smtClean="0"/>
+              <a:rPr lang="en-US"/>
               <a:t>Click to edit Master text styles</a:t>
             </a:r>
           </a:p>
           <a:p>
             <a:pPr lvl="1"/>
             <a:r>
-              <a:rPr lang="en-US" smtClean="0"/>
+              <a:rPr lang="en-US"/>
               <a:t>Second level</a:t>
             </a:r>
           </a:p>
           <a:p>
             <a:pPr lvl="2"/>
             <a:r>
-              <a:rPr lang="en-US" smtClean="0"/>
+              <a:rPr lang="en-US"/>
               <a:t>Third level</a:t>
             </a:r>
           </a:p>
           <a:p>
             <a:pPr lvl="3"/>
             <a:r>
-              <a:rPr lang="en-US" smtClean="0"/>
+              <a:rPr lang="en-US"/>
               <a:t>Fourth level</a:t>
             </a:r>
           </a:p>
           <a:p>
             <a:pPr lvl="4"/>
             <a:r>
-              <a:rPr lang="en-US" smtClean="0"/>
+              <a:rPr lang="en-US"/>
               <a:t>Fifth level</a:t>
             </a:r>
-            <a:endParaRPr lang="en-US"/>
           </a:p>
         </p:txBody>
       </p:sp>
@@ -1778,7 +1779,7 @@
           <a:p>
             <a:fld id="{5BCAD085-E8A6-8845-BD4E-CB4CCA059FC4}" type="datetimeFigureOut">
               <a:rPr lang="en-US" smtClean="0"/>
-              <a:t>1/27/13</a:t>
+              <a:t>3/25/2026</a:t>
             </a:fld>
             <a:endParaRPr lang="en-US"/>
           </a:p>
@@ -1872,10 +1873,9 @@
           <a:lstStyle/>
           <a:p>
             <a:r>
-              <a:rPr lang="en-US" smtClean="0"/>
+              <a:rPr lang="en-US"/>
               <a:t>Click to edit Master title style</a:t>
             </a:r>
-            <a:endParaRPr lang="en-US"/>
           </a:p>
         </p:txBody>
       </p:sp>
@@ -1896,7 +1896,7 @@
           <a:p>
             <a:fld id="{5BCAD085-E8A6-8845-BD4E-CB4CCA059FC4}" type="datetimeFigureOut">
               <a:rPr lang="en-US" smtClean="0"/>
-              <a:t>1/27/13</a:t>
+              <a:t>3/25/2026</a:t>
             </a:fld>
             <a:endParaRPr lang="en-US"/>
           </a:p>
@@ -1991,7 +1991,7 @@
           <a:p>
             <a:fld id="{5BCAD085-E8A6-8845-BD4E-CB4CCA059FC4}" type="datetimeFigureOut">
               <a:rPr lang="en-US" smtClean="0"/>
-              <a:t>1/27/13</a:t>
+              <a:t>3/25/2026</a:t>
             </a:fld>
             <a:endParaRPr lang="en-US"/>
           </a:p>
@@ -2094,10 +2094,9 @@
           </a:lstStyle>
           <a:p>
             <a:r>
-              <a:rPr lang="en-US" smtClean="0"/>
+              <a:rPr lang="en-US"/>
               <a:t>Click to edit Master title style</a:t>
             </a:r>
-            <a:endParaRPr lang="en-US"/>
           </a:p>
         </p:txBody>
       </p:sp>
@@ -2151,38 +2150,37 @@
           <a:p>
             <a:pPr lvl="0"/>
             <a:r>
-              <a:rPr lang="en-US" smtClean="0"/>
+              <a:rPr lang="en-US"/>
               <a:t>Click to edit Master text styles</a:t>
             </a:r>
           </a:p>
           <a:p>
             <a:pPr lvl="1"/>
             <a:r>
-              <a:rPr lang="en-US" smtClean="0"/>
+              <a:rPr lang="en-US"/>
               <a:t>Second level</a:t>
             </a:r>
           </a:p>
           <a:p>
             <a:pPr lvl="2"/>
             <a:r>
-              <a:rPr lang="en-US" smtClean="0"/>
+              <a:rPr lang="en-US"/>
               <a:t>Third level</a:t>
             </a:r>
           </a:p>
           <a:p>
             <a:pPr lvl="3"/>
             <a:r>
-              <a:rPr lang="en-US" smtClean="0"/>
+              <a:rPr lang="en-US"/>
               <a:t>Fourth level</a:t>
             </a:r>
           </a:p>
           <a:p>
             <a:pPr lvl="4"/>
             <a:r>
-              <a:rPr lang="en-US" smtClean="0"/>
+              <a:rPr lang="en-US"/>
               <a:t>Fifth level</a:t>
             </a:r>
-            <a:endParaRPr lang="en-US"/>
           </a:p>
         </p:txBody>
       </p:sp>
@@ -2245,7 +2243,7 @@
           <a:p>
             <a:pPr lvl="0"/>
             <a:r>
-              <a:rPr lang="en-US" smtClean="0"/>
+              <a:rPr lang="en-US"/>
               <a:t>Click to edit Master text styles</a:t>
             </a:r>
           </a:p>
@@ -2268,7 +2266,7 @@
           <a:p>
             <a:fld id="{5BCAD085-E8A6-8845-BD4E-CB4CCA059FC4}" type="datetimeFigureOut">
               <a:rPr lang="en-US" smtClean="0"/>
-              <a:t>1/27/13</a:t>
+              <a:t>3/25/2026</a:t>
             </a:fld>
             <a:endParaRPr lang="en-US"/>
           </a:p>
@@ -2371,10 +2369,9 @@
           </a:lstStyle>
           <a:p>
             <a:r>
-              <a:rPr lang="en-US" smtClean="0"/>
+              <a:rPr lang="en-US"/>
               <a:t>Click to edit Master title style</a:t>
             </a:r>
-            <a:endParaRPr lang="en-US"/>
           </a:p>
         </p:txBody>
       </p:sp>
@@ -2498,7 +2495,7 @@
           <a:p>
             <a:pPr lvl="0"/>
             <a:r>
-              <a:rPr lang="en-US" smtClean="0"/>
+              <a:rPr lang="en-US"/>
               <a:t>Click to edit Master text styles</a:t>
             </a:r>
           </a:p>
@@ -2521,7 +2518,7 @@
           <a:p>
             <a:fld id="{5BCAD085-E8A6-8845-BD4E-CB4CCA059FC4}" type="datetimeFigureOut">
               <a:rPr lang="en-US" smtClean="0"/>
-              <a:t>1/27/13</a:t>
+              <a:t>3/25/2026</a:t>
             </a:fld>
             <a:endParaRPr lang="en-US"/>
           </a:p>
@@ -2630,10 +2627,9 @@
           <a:lstStyle/>
           <a:p>
             <a:r>
-              <a:rPr lang="en-US" smtClean="0"/>
+              <a:rPr lang="en-US"/>
               <a:t>Click to edit Master title style</a:t>
             </a:r>
-            <a:endParaRPr lang="en-US"/>
           </a:p>
         </p:txBody>
       </p:sp>
@@ -2664,38 +2660,37 @@
           <a:p>
             <a:pPr lvl="0"/>
             <a:r>
-              <a:rPr lang="en-US" smtClean="0"/>
+              <a:rPr lang="en-US"/>
               <a:t>Click to edit Master text styles</a:t>
             </a:r>
           </a:p>
           <a:p>
             <a:pPr lvl="1"/>
             <a:r>
-              <a:rPr lang="en-US" smtClean="0"/>
+              <a:rPr lang="en-US"/>
               <a:t>Second level</a:t>
             </a:r>
           </a:p>
           <a:p>
             <a:pPr lvl="2"/>
             <a:r>
-              <a:rPr lang="en-US" smtClean="0"/>
+              <a:rPr lang="en-US"/>
               <a:t>Third level</a:t>
             </a:r>
           </a:p>
           <a:p>
             <a:pPr lvl="3"/>
             <a:r>
-              <a:rPr lang="en-US" smtClean="0"/>
+              <a:rPr lang="en-US"/>
               <a:t>Fourth level</a:t>
             </a:r>
           </a:p>
           <a:p>
             <a:pPr lvl="4"/>
             <a:r>
-              <a:rPr lang="en-US" smtClean="0"/>
+              <a:rPr lang="en-US"/>
               <a:t>Fifth level</a:t>
             </a:r>
-            <a:endParaRPr lang="en-US"/>
           </a:p>
         </p:txBody>
       </p:sp>
@@ -2734,7 +2729,7 @@
           <a:p>
             <a:fld id="{5BCAD085-E8A6-8845-BD4E-CB4CCA059FC4}" type="datetimeFigureOut">
               <a:rPr lang="en-US" smtClean="0"/>
-              <a:t>1/27/13</a:t>
+              <a:t>3/25/2026</a:t>
             </a:fld>
             <a:endParaRPr lang="en-US"/>
           </a:p>
@@ -3093,7 +3088,7 @@
 </file>
 
 <file path=ppt/slides/slide1.xml><?xml version="1.0" encoding="utf-8"?>
-<p:sld xmlns:a="http://schemas.openxmlformats.org/drawingml/2006/main" xmlns:p="http://schemas.openxmlformats.org/presentationml/2006/main" xmlns:r="http://schemas.openxmlformats.org/officeDocument/2006/relationships">
+<p:sld xmlns:a="http://schemas.openxmlformats.org/drawingml/2006/main" xmlns:r="http://schemas.openxmlformats.org/officeDocument/2006/relationships" xmlns:p="http://schemas.openxmlformats.org/presentationml/2006/main">
   <p:cSld>
     <p:spTree>
       <p:nvGrpSpPr>
@@ -3101,7 +3096,14 @@
         <p:cNvGrpSpPr/>
         <p:nvPr/>
       </p:nvGrpSpPr>
-      <p:grpSpPr/>
+      <p:grpSpPr>
+        <a:xfrm>
+          <a:off x="0" y="0"/>
+          <a:ext cx="0" cy="0"/>
+          <a:chOff x="0" y="0"/>
+          <a:chExt cx="0" cy="0"/>
+        </a:xfrm>
+      </p:grpSpPr>
       <p:sp>
         <p:nvSpPr>
           <p:cNvPr id="2" name="Rectangle 1"/>
@@ -3138,7 +3140,7 @@
           </a:fontRef>
         </p:style>
         <p:txBody>
-          <a:bodyPr rtlCol="0" anchor="ctr" wrap="square"/>
+          <a:bodyPr wrap="square" rtlCol="0" anchor="ctr"/>
           <a:lstStyle/>
           <a:p>
             <a:pPr algn="l">
@@ -3356,7 +3358,7 @@
 </file>
 
 <file path=ppt/slides/slide10.xml><?xml version="1.0" encoding="utf-8"?>
-<p:sld xmlns:a="http://schemas.openxmlformats.org/drawingml/2006/main" xmlns:p="http://schemas.openxmlformats.org/presentationml/2006/main" xmlns:r="http://schemas.openxmlformats.org/officeDocument/2006/relationships">
+<p:sld xmlns:a="http://schemas.openxmlformats.org/drawingml/2006/main" xmlns:r="http://schemas.openxmlformats.org/officeDocument/2006/relationships" xmlns:p="http://schemas.openxmlformats.org/presentationml/2006/main">
   <p:cSld>
     <p:spTree>
       <p:nvGrpSpPr>
@@ -3364,7 +3366,14 @@
         <p:cNvGrpSpPr/>
         <p:nvPr/>
       </p:nvGrpSpPr>
-      <p:grpSpPr/>
+      <p:grpSpPr>
+        <a:xfrm>
+          <a:off x="0" y="0"/>
+          <a:ext cx="0" cy="0"/>
+          <a:chOff x="0" y="0"/>
+          <a:chExt cx="0" cy="0"/>
+        </a:xfrm>
+      </p:grpSpPr>
       <p:sp>
         <p:nvSpPr>
           <p:cNvPr id="2" name="Rectangle 1"/>
@@ -3401,7 +3410,7 @@
           </a:fontRef>
         </p:style>
         <p:txBody>
-          <a:bodyPr rtlCol="0" anchor="ctr" wrap="square"/>
+          <a:bodyPr wrap="square" rtlCol="0" anchor="ctr"/>
           <a:lstStyle/>
           <a:p>
             <a:pPr algn="l">
@@ -3521,10 +3530,34 @@
                 <a:tableStyleId>{5C22544A-7EE6-4342-B048-85BDC9FD1C3A}</a:tableStyleId>
               </a:tblPr>
               <a:tblGrid>
-                <a:gridCol w="1458095"/>
-                <a:gridCol w="844160"/>
-                <a:gridCol w="3069674"/>
-                <a:gridCol w="4988221"/>
+                <a:gridCol w="1458095">
+                  <a:extLst>
+                    <a:ext uri="{9D8B030D-6E8A-4147-A177-3AD203B41FA5}">
+                      <a16:colId xmlns:a16="http://schemas.microsoft.com/office/drawing/2014/main" val="20000"/>
+                    </a:ext>
+                  </a:extLst>
+                </a:gridCol>
+                <a:gridCol w="844160">
+                  <a:extLst>
+                    <a:ext uri="{9D8B030D-6E8A-4147-A177-3AD203B41FA5}">
+                      <a16:colId xmlns:a16="http://schemas.microsoft.com/office/drawing/2014/main" val="20001"/>
+                    </a:ext>
+                  </a:extLst>
+                </a:gridCol>
+                <a:gridCol w="3069674">
+                  <a:extLst>
+                    <a:ext uri="{9D8B030D-6E8A-4147-A177-3AD203B41FA5}">
+                      <a16:colId xmlns:a16="http://schemas.microsoft.com/office/drawing/2014/main" val="20002"/>
+                    </a:ext>
+                  </a:extLst>
+                </a:gridCol>
+                <a:gridCol w="4988221">
+                  <a:extLst>
+                    <a:ext uri="{9D8B030D-6E8A-4147-A177-3AD203B41FA5}">
+                      <a16:colId xmlns:a16="http://schemas.microsoft.com/office/drawing/2014/main" val="20003"/>
+                    </a:ext>
+                  </a:extLst>
+                </a:gridCol>
               </a:tblGrid>
               <a:tr h="320040">
                 <a:tc>
@@ -3623,6 +3656,11 @@
                     </a:solidFill>
                   </a:tcPr>
                 </a:tc>
+                <a:extLst>
+                  <a:ext uri="{0D108BD9-81ED-4DB2-BD59-A6C34878D82A}">
+                    <a16:rowId xmlns:a16="http://schemas.microsoft.com/office/drawing/2014/main" val="10000"/>
+                  </a:ext>
+                </a:extLst>
               </a:tr>
               <a:tr h="320040">
                 <a:tc>
@@ -3705,6 +3743,11 @@
                   </a:txBody>
                   <a:tcPr anchor="ctr"/>
                 </a:tc>
+                <a:extLst>
+                  <a:ext uri="{0D108BD9-81ED-4DB2-BD59-A6C34878D82A}">
+                    <a16:rowId xmlns:a16="http://schemas.microsoft.com/office/drawing/2014/main" val="10001"/>
+                  </a:ext>
+                </a:extLst>
               </a:tr>
               <a:tr h="320040">
                 <a:tc>
@@ -3803,6 +3846,11 @@
                     </a:solidFill>
                   </a:tcPr>
                 </a:tc>
+                <a:extLst>
+                  <a:ext uri="{0D108BD9-81ED-4DB2-BD59-A6C34878D82A}">
+                    <a16:rowId xmlns:a16="http://schemas.microsoft.com/office/drawing/2014/main" val="10002"/>
+                  </a:ext>
+                </a:extLst>
               </a:tr>
               <a:tr h="320040">
                 <a:tc>
@@ -3885,6 +3933,11 @@
                   </a:txBody>
                   <a:tcPr anchor="ctr"/>
                 </a:tc>
+                <a:extLst>
+                  <a:ext uri="{0D108BD9-81ED-4DB2-BD59-A6C34878D82A}">
+                    <a16:rowId xmlns:a16="http://schemas.microsoft.com/office/drawing/2014/main" val="10003"/>
+                  </a:ext>
+                </a:extLst>
               </a:tr>
               <a:tr h="320040">
                 <a:tc>
@@ -3983,6 +4036,11 @@
                     </a:solidFill>
                   </a:tcPr>
                 </a:tc>
+                <a:extLst>
+                  <a:ext uri="{0D108BD9-81ED-4DB2-BD59-A6C34878D82A}">
+                    <a16:rowId xmlns:a16="http://schemas.microsoft.com/office/drawing/2014/main" val="10004"/>
+                  </a:ext>
+                </a:extLst>
               </a:tr>
             </a:tbl>
           </a:graphicData>
@@ -4028,6 +4086,7 @@
           <a:lstStyle/>
           <a:p>
             <a:pPr algn="ctr"/>
+            <a:endParaRPr/>
           </a:p>
         </p:txBody>
       </p:sp>
@@ -4071,6 +4130,7 @@
           <a:lstStyle/>
           <a:p>
             <a:pPr algn="ctr"/>
+            <a:endParaRPr/>
           </a:p>
         </p:txBody>
       </p:sp>
@@ -4091,7 +4151,7 @@
           <a:noFill/>
         </p:spPr>
         <p:txBody>
-          <a:bodyPr wrap="square" a:anchor="ctr"/>
+          <a:bodyPr wrap="square"/>
           <a:lstStyle/>
           <a:p>
             <a:pPr>
@@ -4117,7 +4177,7 @@
 </file>
 
 <file path=ppt/slides/slide11.xml><?xml version="1.0" encoding="utf-8"?>
-<p:sld xmlns:a="http://schemas.openxmlformats.org/drawingml/2006/main" xmlns:p="http://schemas.openxmlformats.org/presentationml/2006/main" xmlns:r="http://schemas.openxmlformats.org/officeDocument/2006/relationships">
+<p:sld xmlns:a="http://schemas.openxmlformats.org/drawingml/2006/main" xmlns:r="http://schemas.openxmlformats.org/officeDocument/2006/relationships" xmlns:p="http://schemas.openxmlformats.org/presentationml/2006/main">
   <p:cSld>
     <p:spTree>
       <p:nvGrpSpPr>
@@ -4125,7 +4185,14 @@
         <p:cNvGrpSpPr/>
         <p:nvPr/>
       </p:nvGrpSpPr>
-      <p:grpSpPr/>
+      <p:grpSpPr>
+        <a:xfrm>
+          <a:off x="0" y="0"/>
+          <a:ext cx="0" cy="0"/>
+          <a:chOff x="0" y="0"/>
+          <a:chExt cx="0" cy="0"/>
+        </a:xfrm>
+      </p:grpSpPr>
       <p:sp>
         <p:nvSpPr>
           <p:cNvPr id="2" name="Rectangle 1"/>
@@ -4162,7 +4229,7 @@
           </a:fontRef>
         </p:style>
         <p:txBody>
-          <a:bodyPr rtlCol="0" anchor="ctr" wrap="square"/>
+          <a:bodyPr wrap="square" rtlCol="0" anchor="ctr"/>
           <a:lstStyle/>
           <a:p>
             <a:pPr algn="l">
@@ -4432,7 +4499,7 @@
 </file>
 
 <file path=ppt/slides/slide12.xml><?xml version="1.0" encoding="utf-8"?>
-<p:sld xmlns:a="http://schemas.openxmlformats.org/drawingml/2006/main" xmlns:p="http://schemas.openxmlformats.org/presentationml/2006/main" xmlns:r="http://schemas.openxmlformats.org/officeDocument/2006/relationships">
+<p:sld xmlns:a="http://schemas.openxmlformats.org/drawingml/2006/main" xmlns:r="http://schemas.openxmlformats.org/officeDocument/2006/relationships" xmlns:p="http://schemas.openxmlformats.org/presentationml/2006/main">
   <p:cSld>
     <p:spTree>
       <p:nvGrpSpPr>
@@ -4440,7 +4507,14 @@
         <p:cNvGrpSpPr/>
         <p:nvPr/>
       </p:nvGrpSpPr>
-      <p:grpSpPr/>
+      <p:grpSpPr>
+        <a:xfrm>
+          <a:off x="0" y="0"/>
+          <a:ext cx="0" cy="0"/>
+          <a:chOff x="0" y="0"/>
+          <a:chExt cx="0" cy="0"/>
+        </a:xfrm>
+      </p:grpSpPr>
       <p:sp>
         <p:nvSpPr>
           <p:cNvPr id="2" name="Rectangle 1"/>
@@ -4477,7 +4551,7 @@
           </a:fontRef>
         </p:style>
         <p:txBody>
-          <a:bodyPr rtlCol="0" anchor="ctr" wrap="square"/>
+          <a:bodyPr wrap="square" rtlCol="0" anchor="ctr"/>
           <a:lstStyle/>
           <a:p>
             <a:pPr algn="l">
@@ -4621,9 +4695,27 @@
                 <a:tableStyleId>{5C22544A-7EE6-4342-B048-85BDC9FD1C3A}</a:tableStyleId>
               </a:tblPr>
               <a:tblGrid>
-                <a:gridCol w="3028352"/>
-                <a:gridCol w="3347126"/>
-                <a:gridCol w="3984673"/>
+                <a:gridCol w="3028352">
+                  <a:extLst>
+                    <a:ext uri="{9D8B030D-6E8A-4147-A177-3AD203B41FA5}">
+                      <a16:colId xmlns:a16="http://schemas.microsoft.com/office/drawing/2014/main" val="20000"/>
+                    </a:ext>
+                  </a:extLst>
+                </a:gridCol>
+                <a:gridCol w="3347126">
+                  <a:extLst>
+                    <a:ext uri="{9D8B030D-6E8A-4147-A177-3AD203B41FA5}">
+                      <a16:colId xmlns:a16="http://schemas.microsoft.com/office/drawing/2014/main" val="20001"/>
+                    </a:ext>
+                  </a:extLst>
+                </a:gridCol>
+                <a:gridCol w="3984673">
+                  <a:extLst>
+                    <a:ext uri="{9D8B030D-6E8A-4147-A177-3AD203B41FA5}">
+                      <a16:colId xmlns:a16="http://schemas.microsoft.com/office/drawing/2014/main" val="20002"/>
+                    </a:ext>
+                  </a:extLst>
+                </a:gridCol>
               </a:tblGrid>
               <a:tr h="320040">
                 <a:tc>
@@ -4698,6 +4790,11 @@
                     </a:solidFill>
                   </a:tcPr>
                 </a:tc>
+                <a:extLst>
+                  <a:ext uri="{0D108BD9-81ED-4DB2-BD59-A6C34878D82A}">
+                    <a16:rowId xmlns:a16="http://schemas.microsoft.com/office/drawing/2014/main" val="10000"/>
+                  </a:ext>
+                </a:extLst>
               </a:tr>
               <a:tr h="320040">
                 <a:tc>
@@ -4760,6 +4857,11 @@
                   </a:txBody>
                   <a:tcPr anchor="ctr"/>
                 </a:tc>
+                <a:extLst>
+                  <a:ext uri="{0D108BD9-81ED-4DB2-BD59-A6C34878D82A}">
+                    <a16:rowId xmlns:a16="http://schemas.microsoft.com/office/drawing/2014/main" val="10001"/>
+                  </a:ext>
+                </a:extLst>
               </a:tr>
               <a:tr h="320040">
                 <a:tc>
@@ -4834,6 +4936,11 @@
                     </a:solidFill>
                   </a:tcPr>
                 </a:tc>
+                <a:extLst>
+                  <a:ext uri="{0D108BD9-81ED-4DB2-BD59-A6C34878D82A}">
+                    <a16:rowId xmlns:a16="http://schemas.microsoft.com/office/drawing/2014/main" val="10002"/>
+                  </a:ext>
+                </a:extLst>
               </a:tr>
             </a:tbl>
           </a:graphicData>
@@ -4879,6 +4986,7 @@
           <a:lstStyle/>
           <a:p>
             <a:pPr algn="ctr"/>
+            <a:endParaRPr/>
           </a:p>
         </p:txBody>
       </p:sp>
@@ -4922,6 +5030,7 @@
           <a:lstStyle/>
           <a:p>
             <a:pPr algn="ctr"/>
+            <a:endParaRPr/>
           </a:p>
         </p:txBody>
       </p:sp>
@@ -4942,11 +5051,11 @@
           <a:noFill/>
         </p:spPr>
         <p:txBody>
-          <a:bodyPr wrap="square" a:anchor="ctr"/>
+          <a:bodyPr wrap="square"/>
           <a:lstStyle/>
           <a:p>
             <a:r>
-              <a:rPr b="1" sz="1100">
+              <a:rPr sz="1100" b="1">
                 <a:solidFill>
                   <a:srgbClr val="29065A"/>
                 </a:solidFill>
@@ -5006,6 +5115,7 @@
           <a:lstStyle/>
           <a:p>
             <a:pPr algn="ctr"/>
+            <a:endParaRPr/>
           </a:p>
         </p:txBody>
       </p:sp>
@@ -5049,6 +5159,7 @@
           <a:lstStyle/>
           <a:p>
             <a:pPr algn="ctr"/>
+            <a:endParaRPr/>
           </a:p>
         </p:txBody>
       </p:sp>
@@ -5069,11 +5180,11 @@
           <a:noFill/>
         </p:spPr>
         <p:txBody>
-          <a:bodyPr wrap="square" a:anchor="ctr"/>
+          <a:bodyPr wrap="square"/>
           <a:lstStyle/>
           <a:p>
             <a:r>
-              <a:rPr b="1" sz="1100">
+              <a:rPr sz="1100" b="1">
                 <a:solidFill>
                   <a:srgbClr val="29065A"/>
                 </a:solidFill>
@@ -5102,7 +5213,7 @@
 </file>
 
 <file path=ppt/slides/slide13.xml><?xml version="1.0" encoding="utf-8"?>
-<p:sld xmlns:a="http://schemas.openxmlformats.org/drawingml/2006/main" xmlns:p="http://schemas.openxmlformats.org/presentationml/2006/main" xmlns:r="http://schemas.openxmlformats.org/officeDocument/2006/relationships">
+<p:sld xmlns:a="http://schemas.openxmlformats.org/drawingml/2006/main" xmlns:r="http://schemas.openxmlformats.org/officeDocument/2006/relationships" xmlns:p="http://schemas.openxmlformats.org/presentationml/2006/main">
   <p:cSld>
     <p:spTree>
       <p:nvGrpSpPr>
@@ -5110,7 +5221,14 @@
         <p:cNvGrpSpPr/>
         <p:nvPr/>
       </p:nvGrpSpPr>
-      <p:grpSpPr/>
+      <p:grpSpPr>
+        <a:xfrm>
+          <a:off x="0" y="0"/>
+          <a:ext cx="0" cy="0"/>
+          <a:chOff x="0" y="0"/>
+          <a:chExt cx="0" cy="0"/>
+        </a:xfrm>
+      </p:grpSpPr>
       <p:sp>
         <p:nvSpPr>
           <p:cNvPr id="2" name="Rectangle 1"/>
@@ -5147,7 +5265,7 @@
           </a:fontRef>
         </p:style>
         <p:txBody>
-          <a:bodyPr rtlCol="0" anchor="ctr" wrap="square"/>
+          <a:bodyPr wrap="square" rtlCol="0" anchor="ctr"/>
           <a:lstStyle/>
           <a:p>
             <a:pPr algn="l">
@@ -5433,7 +5551,7 @@
 </file>
 
 <file path=ppt/slides/slide14.xml><?xml version="1.0" encoding="utf-8"?>
-<p:sld xmlns:a="http://schemas.openxmlformats.org/drawingml/2006/main" xmlns:p="http://schemas.openxmlformats.org/presentationml/2006/main" xmlns:r="http://schemas.openxmlformats.org/officeDocument/2006/relationships">
+<p:sld xmlns:a="http://schemas.openxmlformats.org/drawingml/2006/main" xmlns:r="http://schemas.openxmlformats.org/officeDocument/2006/relationships" xmlns:p="http://schemas.openxmlformats.org/presentationml/2006/main">
   <p:cSld>
     <p:spTree>
       <p:nvGrpSpPr>
@@ -5441,7 +5559,14 @@
         <p:cNvGrpSpPr/>
         <p:nvPr/>
       </p:nvGrpSpPr>
-      <p:grpSpPr/>
+      <p:grpSpPr>
+        <a:xfrm>
+          <a:off x="0" y="0"/>
+          <a:ext cx="0" cy="0"/>
+          <a:chOff x="0" y="0"/>
+          <a:chExt cx="0" cy="0"/>
+        </a:xfrm>
+      </p:grpSpPr>
       <p:sp>
         <p:nvSpPr>
           <p:cNvPr id="2" name="Rectangle 1"/>
@@ -5478,7 +5603,7 @@
           </a:fontRef>
         </p:style>
         <p:txBody>
-          <a:bodyPr rtlCol="0" anchor="ctr" wrap="square"/>
+          <a:bodyPr wrap="square" rtlCol="0" anchor="ctr"/>
           <a:lstStyle/>
           <a:p>
             <a:pPr algn="l">
@@ -5598,10 +5723,34 @@
                 <a:tableStyleId>{5C22544A-7EE6-4342-B048-85BDC9FD1C3A}</a:tableStyleId>
               </a:tblPr>
               <a:tblGrid>
-                <a:gridCol w="3719028"/>
-                <a:gridCol w="1593869"/>
-                <a:gridCol w="2390804"/>
-                <a:gridCol w="2656449"/>
+                <a:gridCol w="3719028">
+                  <a:extLst>
+                    <a:ext uri="{9D8B030D-6E8A-4147-A177-3AD203B41FA5}">
+                      <a16:colId xmlns:a16="http://schemas.microsoft.com/office/drawing/2014/main" val="20000"/>
+                    </a:ext>
+                  </a:extLst>
+                </a:gridCol>
+                <a:gridCol w="1593869">
+                  <a:extLst>
+                    <a:ext uri="{9D8B030D-6E8A-4147-A177-3AD203B41FA5}">
+                      <a16:colId xmlns:a16="http://schemas.microsoft.com/office/drawing/2014/main" val="20001"/>
+                    </a:ext>
+                  </a:extLst>
+                </a:gridCol>
+                <a:gridCol w="2390804">
+                  <a:extLst>
+                    <a:ext uri="{9D8B030D-6E8A-4147-A177-3AD203B41FA5}">
+                      <a16:colId xmlns:a16="http://schemas.microsoft.com/office/drawing/2014/main" val="20002"/>
+                    </a:ext>
+                  </a:extLst>
+                </a:gridCol>
+                <a:gridCol w="2656449">
+                  <a:extLst>
+                    <a:ext uri="{9D8B030D-6E8A-4147-A177-3AD203B41FA5}">
+                      <a16:colId xmlns:a16="http://schemas.microsoft.com/office/drawing/2014/main" val="20003"/>
+                    </a:ext>
+                  </a:extLst>
+                </a:gridCol>
               </a:tblGrid>
               <a:tr h="320040">
                 <a:tc>
@@ -5700,6 +5849,11 @@
                     </a:solidFill>
                   </a:tcPr>
                 </a:tc>
+                <a:extLst>
+                  <a:ext uri="{0D108BD9-81ED-4DB2-BD59-A6C34878D82A}">
+                    <a16:rowId xmlns:a16="http://schemas.microsoft.com/office/drawing/2014/main" val="10000"/>
+                  </a:ext>
+                </a:extLst>
               </a:tr>
               <a:tr h="320040">
                 <a:tc>
@@ -5782,6 +5936,11 @@
                   </a:txBody>
                   <a:tcPr anchor="ctr"/>
                 </a:tc>
+                <a:extLst>
+                  <a:ext uri="{0D108BD9-81ED-4DB2-BD59-A6C34878D82A}">
+                    <a16:rowId xmlns:a16="http://schemas.microsoft.com/office/drawing/2014/main" val="10001"/>
+                  </a:ext>
+                </a:extLst>
               </a:tr>
               <a:tr h="320040">
                 <a:tc>
@@ -5880,6 +6039,11 @@
                     </a:solidFill>
                   </a:tcPr>
                 </a:tc>
+                <a:extLst>
+                  <a:ext uri="{0D108BD9-81ED-4DB2-BD59-A6C34878D82A}">
+                    <a16:rowId xmlns:a16="http://schemas.microsoft.com/office/drawing/2014/main" val="10002"/>
+                  </a:ext>
+                </a:extLst>
               </a:tr>
             </a:tbl>
           </a:graphicData>
@@ -5925,6 +6089,7 @@
           <a:lstStyle/>
           <a:p>
             <a:pPr algn="ctr"/>
+            <a:endParaRPr/>
           </a:p>
         </p:txBody>
       </p:sp>
@@ -5968,6 +6133,7 @@
           <a:lstStyle/>
           <a:p>
             <a:pPr algn="ctr"/>
+            <a:endParaRPr/>
           </a:p>
         </p:txBody>
       </p:sp>
@@ -5988,11 +6154,11 @@
           <a:noFill/>
         </p:spPr>
         <p:txBody>
-          <a:bodyPr wrap="square" a:anchor="ctr"/>
+          <a:bodyPr wrap="square"/>
           <a:lstStyle/>
           <a:p>
             <a:r>
-              <a:rPr b="1" sz="1100">
+              <a:rPr sz="1100" b="1">
                 <a:solidFill>
                   <a:srgbClr val="29065A"/>
                 </a:solidFill>
@@ -6021,7 +6187,7 @@
 </file>
 
 <file path=ppt/slides/slide15.xml><?xml version="1.0" encoding="utf-8"?>
-<p:sld xmlns:a="http://schemas.openxmlformats.org/drawingml/2006/main" xmlns:p="http://schemas.openxmlformats.org/presentationml/2006/main" xmlns:r="http://schemas.openxmlformats.org/officeDocument/2006/relationships">
+<p:sld xmlns:a="http://schemas.openxmlformats.org/drawingml/2006/main" xmlns:r="http://schemas.openxmlformats.org/officeDocument/2006/relationships" xmlns:p="http://schemas.openxmlformats.org/presentationml/2006/main">
   <p:cSld>
     <p:spTree>
       <p:nvGrpSpPr>
@@ -6029,7 +6195,14 @@
         <p:cNvGrpSpPr/>
         <p:nvPr/>
       </p:nvGrpSpPr>
-      <p:grpSpPr/>
+      <p:grpSpPr>
+        <a:xfrm>
+          <a:off x="0" y="0"/>
+          <a:ext cx="0" cy="0"/>
+          <a:chOff x="0" y="0"/>
+          <a:chExt cx="0" cy="0"/>
+        </a:xfrm>
+      </p:grpSpPr>
       <p:sp>
         <p:nvSpPr>
           <p:cNvPr id="2" name="Rectangle 1"/>
@@ -6066,7 +6239,7 @@
           </a:fontRef>
         </p:style>
         <p:txBody>
-          <a:bodyPr rtlCol="0" anchor="ctr" wrap="square"/>
+          <a:bodyPr wrap="square" rtlCol="0" anchor="ctr"/>
           <a:lstStyle/>
           <a:p>
             <a:pPr algn="l">
@@ -6177,7 +6350,7 @@
         </p:nvGraphicFramePr>
         <p:xfrm>
           <a:off x="914400" y="960120"/>
-          <a:ext cx="10360150" cy="5120640"/>
+          <a:ext cx="10360150" cy="5212080"/>
         </p:xfrm>
         <a:graphic>
           <a:graphicData uri="http://schemas.openxmlformats.org/drawingml/2006/table">
@@ -6186,9 +6359,27 @@
                 <a:tableStyleId>{5C22544A-7EE6-4342-B048-85BDC9FD1C3A}</a:tableStyleId>
               </a:tblPr>
               <a:tblGrid>
-                <a:gridCol w="240933"/>
-                <a:gridCol w="4577741"/>
-                <a:gridCol w="5541476"/>
+                <a:gridCol w="240933">
+                  <a:extLst>
+                    <a:ext uri="{9D8B030D-6E8A-4147-A177-3AD203B41FA5}">
+                      <a16:colId xmlns:a16="http://schemas.microsoft.com/office/drawing/2014/main" val="20000"/>
+                    </a:ext>
+                  </a:extLst>
+                </a:gridCol>
+                <a:gridCol w="4577741">
+                  <a:extLst>
+                    <a:ext uri="{9D8B030D-6E8A-4147-A177-3AD203B41FA5}">
+                      <a16:colId xmlns:a16="http://schemas.microsoft.com/office/drawing/2014/main" val="20001"/>
+                    </a:ext>
+                  </a:extLst>
+                </a:gridCol>
+                <a:gridCol w="5541476">
+                  <a:extLst>
+                    <a:ext uri="{9D8B030D-6E8A-4147-A177-3AD203B41FA5}">
+                      <a16:colId xmlns:a16="http://schemas.microsoft.com/office/drawing/2014/main" val="20002"/>
+                    </a:ext>
+                  </a:extLst>
+                </a:gridCol>
               </a:tblGrid>
               <a:tr h="320040">
                 <a:tc>
@@ -6263,6 +6454,11 @@
                     </a:solidFill>
                   </a:tcPr>
                 </a:tc>
+                <a:extLst>
+                  <a:ext uri="{0D108BD9-81ED-4DB2-BD59-A6C34878D82A}">
+                    <a16:rowId xmlns:a16="http://schemas.microsoft.com/office/drawing/2014/main" val="10000"/>
+                  </a:ext>
+                </a:extLst>
               </a:tr>
               <a:tr h="320040">
                 <a:tc>
@@ -6325,6 +6521,11 @@
                   </a:txBody>
                   <a:tcPr anchor="ctr"/>
                 </a:tc>
+                <a:extLst>
+                  <a:ext uri="{0D108BD9-81ED-4DB2-BD59-A6C34878D82A}">
+                    <a16:rowId xmlns:a16="http://schemas.microsoft.com/office/drawing/2014/main" val="10001"/>
+                  </a:ext>
+                </a:extLst>
               </a:tr>
               <a:tr h="320040">
                 <a:tc>
@@ -6399,6 +6600,11 @@
                     </a:solidFill>
                   </a:tcPr>
                 </a:tc>
+                <a:extLst>
+                  <a:ext uri="{0D108BD9-81ED-4DB2-BD59-A6C34878D82A}">
+                    <a16:rowId xmlns:a16="http://schemas.microsoft.com/office/drawing/2014/main" val="10002"/>
+                  </a:ext>
+                </a:extLst>
               </a:tr>
               <a:tr h="320040">
                 <a:tc>
@@ -6461,6 +6667,11 @@
                   </a:txBody>
                   <a:tcPr anchor="ctr"/>
                 </a:tc>
+                <a:extLst>
+                  <a:ext uri="{0D108BD9-81ED-4DB2-BD59-A6C34878D82A}">
+                    <a16:rowId xmlns:a16="http://schemas.microsoft.com/office/drawing/2014/main" val="10003"/>
+                  </a:ext>
+                </a:extLst>
               </a:tr>
               <a:tr h="320040">
                 <a:tc>
@@ -6535,6 +6746,11 @@
                     </a:solidFill>
                   </a:tcPr>
                 </a:tc>
+                <a:extLst>
+                  <a:ext uri="{0D108BD9-81ED-4DB2-BD59-A6C34878D82A}">
+                    <a16:rowId xmlns:a16="http://schemas.microsoft.com/office/drawing/2014/main" val="10004"/>
+                  </a:ext>
+                </a:extLst>
               </a:tr>
               <a:tr h="320040">
                 <a:tc>
@@ -6597,6 +6813,11 @@
                   </a:txBody>
                   <a:tcPr anchor="ctr"/>
                 </a:tc>
+                <a:extLst>
+                  <a:ext uri="{0D108BD9-81ED-4DB2-BD59-A6C34878D82A}">
+                    <a16:rowId xmlns:a16="http://schemas.microsoft.com/office/drawing/2014/main" val="10005"/>
+                  </a:ext>
+                </a:extLst>
               </a:tr>
               <a:tr h="320040">
                 <a:tc>
@@ -6671,6 +6892,11 @@
                     </a:solidFill>
                   </a:tcPr>
                 </a:tc>
+                <a:extLst>
+                  <a:ext uri="{0D108BD9-81ED-4DB2-BD59-A6C34878D82A}">
+                    <a16:rowId xmlns:a16="http://schemas.microsoft.com/office/drawing/2014/main" val="10006"/>
+                  </a:ext>
+                </a:extLst>
               </a:tr>
               <a:tr h="320040">
                 <a:tc>
@@ -6733,6 +6959,11 @@
                   </a:txBody>
                   <a:tcPr anchor="ctr"/>
                 </a:tc>
+                <a:extLst>
+                  <a:ext uri="{0D108BD9-81ED-4DB2-BD59-A6C34878D82A}">
+                    <a16:rowId xmlns:a16="http://schemas.microsoft.com/office/drawing/2014/main" val="10007"/>
+                  </a:ext>
+                </a:extLst>
               </a:tr>
               <a:tr h="320040">
                 <a:tc>
@@ -6807,6 +7038,11 @@
                     </a:solidFill>
                   </a:tcPr>
                 </a:tc>
+                <a:extLst>
+                  <a:ext uri="{0D108BD9-81ED-4DB2-BD59-A6C34878D82A}">
+                    <a16:rowId xmlns:a16="http://schemas.microsoft.com/office/drawing/2014/main" val="10008"/>
+                  </a:ext>
+                </a:extLst>
               </a:tr>
               <a:tr h="320040">
                 <a:tc>
@@ -6869,6 +7105,11 @@
                   </a:txBody>
                   <a:tcPr anchor="ctr"/>
                 </a:tc>
+                <a:extLst>
+                  <a:ext uri="{0D108BD9-81ED-4DB2-BD59-A6C34878D82A}">
+                    <a16:rowId xmlns:a16="http://schemas.microsoft.com/office/drawing/2014/main" val="10009"/>
+                  </a:ext>
+                </a:extLst>
               </a:tr>
               <a:tr h="320040">
                 <a:tc>
@@ -6943,6 +7184,11 @@
                     </a:solidFill>
                   </a:tcPr>
                 </a:tc>
+                <a:extLst>
+                  <a:ext uri="{0D108BD9-81ED-4DB2-BD59-A6C34878D82A}">
+                    <a16:rowId xmlns:a16="http://schemas.microsoft.com/office/drawing/2014/main" val="10010"/>
+                  </a:ext>
+                </a:extLst>
               </a:tr>
               <a:tr h="320040">
                 <a:tc>
@@ -7005,6 +7251,11 @@
                   </a:txBody>
                   <a:tcPr anchor="ctr"/>
                 </a:tc>
+                <a:extLst>
+                  <a:ext uri="{0D108BD9-81ED-4DB2-BD59-A6C34878D82A}">
+                    <a16:rowId xmlns:a16="http://schemas.microsoft.com/office/drawing/2014/main" val="10011"/>
+                  </a:ext>
+                </a:extLst>
               </a:tr>
               <a:tr h="320040">
                 <a:tc>
@@ -7079,6 +7330,11 @@
                     </a:solidFill>
                   </a:tcPr>
                 </a:tc>
+                <a:extLst>
+                  <a:ext uri="{0D108BD9-81ED-4DB2-BD59-A6C34878D82A}">
+                    <a16:rowId xmlns:a16="http://schemas.microsoft.com/office/drawing/2014/main" val="10012"/>
+                  </a:ext>
+                </a:extLst>
               </a:tr>
               <a:tr h="320040">
                 <a:tc>
@@ -7141,6 +7397,11 @@
                   </a:txBody>
                   <a:tcPr anchor="ctr"/>
                 </a:tc>
+                <a:extLst>
+                  <a:ext uri="{0D108BD9-81ED-4DB2-BD59-A6C34878D82A}">
+                    <a16:rowId xmlns:a16="http://schemas.microsoft.com/office/drawing/2014/main" val="10013"/>
+                  </a:ext>
+                </a:extLst>
               </a:tr>
               <a:tr h="320040">
                 <a:tc>
@@ -7215,6 +7476,11 @@
                     </a:solidFill>
                   </a:tcPr>
                 </a:tc>
+                <a:extLst>
+                  <a:ext uri="{0D108BD9-81ED-4DB2-BD59-A6C34878D82A}">
+                    <a16:rowId xmlns:a16="http://schemas.microsoft.com/office/drawing/2014/main" val="10014"/>
+                  </a:ext>
+                </a:extLst>
               </a:tr>
               <a:tr h="320040">
                 <a:tc>
@@ -7277,6 +7543,11 @@
                   </a:txBody>
                   <a:tcPr anchor="ctr"/>
                 </a:tc>
+                <a:extLst>
+                  <a:ext uri="{0D108BD9-81ED-4DB2-BD59-A6C34878D82A}">
+                    <a16:rowId xmlns:a16="http://schemas.microsoft.com/office/drawing/2014/main" val="10015"/>
+                  </a:ext>
+                </a:extLst>
               </a:tr>
             </a:tbl>
           </a:graphicData>
@@ -7291,7 +7562,7 @@
 </file>
 
 <file path=ppt/slides/slide2.xml><?xml version="1.0" encoding="utf-8"?>
-<p:sld xmlns:a="http://schemas.openxmlformats.org/drawingml/2006/main" xmlns:p="http://schemas.openxmlformats.org/presentationml/2006/main" xmlns:r="http://schemas.openxmlformats.org/officeDocument/2006/relationships">
+<p:sld xmlns:a="http://schemas.openxmlformats.org/drawingml/2006/main" xmlns:r="http://schemas.openxmlformats.org/officeDocument/2006/relationships" xmlns:p="http://schemas.openxmlformats.org/presentationml/2006/main">
   <p:cSld>
     <p:spTree>
       <p:nvGrpSpPr>
@@ -7299,7 +7570,14 @@
         <p:cNvGrpSpPr/>
         <p:nvPr/>
       </p:nvGrpSpPr>
-      <p:grpSpPr/>
+      <p:grpSpPr>
+        <a:xfrm>
+          <a:off x="0" y="0"/>
+          <a:ext cx="0" cy="0"/>
+          <a:chOff x="0" y="0"/>
+          <a:chExt cx="0" cy="0"/>
+        </a:xfrm>
+      </p:grpSpPr>
       <p:sp>
         <p:nvSpPr>
           <p:cNvPr id="2" name="Rectangle 1"/>
@@ -7336,7 +7614,7 @@
           </a:fontRef>
         </p:style>
         <p:txBody>
-          <a:bodyPr rtlCol="0" anchor="ctr" wrap="square"/>
+          <a:bodyPr wrap="square" rtlCol="0" anchor="ctr"/>
           <a:lstStyle/>
           <a:p>
             <a:pPr algn="l">
@@ -7564,8 +7842,20 @@
                 <a:tableStyleId>{5C22544A-7EE6-4342-B048-85BDC9FD1C3A}</a:tableStyleId>
               </a:tblPr>
               <a:tblGrid>
-                <a:gridCol w="8288121"/>
-                <a:gridCol w="2072030"/>
+                <a:gridCol w="8288121">
+                  <a:extLst>
+                    <a:ext uri="{9D8B030D-6E8A-4147-A177-3AD203B41FA5}">
+                      <a16:colId xmlns:a16="http://schemas.microsoft.com/office/drawing/2014/main" val="20000"/>
+                    </a:ext>
+                  </a:extLst>
+                </a:gridCol>
+                <a:gridCol w="2072030">
+                  <a:extLst>
+                    <a:ext uri="{9D8B030D-6E8A-4147-A177-3AD203B41FA5}">
+                      <a16:colId xmlns:a16="http://schemas.microsoft.com/office/drawing/2014/main" val="20001"/>
+                    </a:ext>
+                  </a:extLst>
+                </a:gridCol>
               </a:tblGrid>
               <a:tr h="320040">
                 <a:tc>
@@ -7616,6 +7906,11 @@
                     </a:solidFill>
                   </a:tcPr>
                 </a:tc>
+                <a:extLst>
+                  <a:ext uri="{0D108BD9-81ED-4DB2-BD59-A6C34878D82A}">
+                    <a16:rowId xmlns:a16="http://schemas.microsoft.com/office/drawing/2014/main" val="10000"/>
+                  </a:ext>
+                </a:extLst>
               </a:tr>
               <a:tr h="320040">
                 <a:tc>
@@ -7658,6 +7953,11 @@
                   </a:txBody>
                   <a:tcPr anchor="ctr"/>
                 </a:tc>
+                <a:extLst>
+                  <a:ext uri="{0D108BD9-81ED-4DB2-BD59-A6C34878D82A}">
+                    <a16:rowId xmlns:a16="http://schemas.microsoft.com/office/drawing/2014/main" val="10001"/>
+                  </a:ext>
+                </a:extLst>
               </a:tr>
               <a:tr h="320040">
                 <a:tc>
@@ -7708,6 +8008,11 @@
                     </a:solidFill>
                   </a:tcPr>
                 </a:tc>
+                <a:extLst>
+                  <a:ext uri="{0D108BD9-81ED-4DB2-BD59-A6C34878D82A}">
+                    <a16:rowId xmlns:a16="http://schemas.microsoft.com/office/drawing/2014/main" val="10002"/>
+                  </a:ext>
+                </a:extLst>
               </a:tr>
               <a:tr h="320040">
                 <a:tc>
@@ -7750,6 +8055,11 @@
                   </a:txBody>
                   <a:tcPr anchor="ctr"/>
                 </a:tc>
+                <a:extLst>
+                  <a:ext uri="{0D108BD9-81ED-4DB2-BD59-A6C34878D82A}">
+                    <a16:rowId xmlns:a16="http://schemas.microsoft.com/office/drawing/2014/main" val="10003"/>
+                  </a:ext>
+                </a:extLst>
               </a:tr>
             </a:tbl>
           </a:graphicData>
@@ -7848,7 +8158,7 @@
 </file>
 
 <file path=ppt/slides/slide3.xml><?xml version="1.0" encoding="utf-8"?>
-<p:sld xmlns:a="http://schemas.openxmlformats.org/drawingml/2006/main" xmlns:p="http://schemas.openxmlformats.org/presentationml/2006/main" xmlns:r="http://schemas.openxmlformats.org/officeDocument/2006/relationships">
+<p:sld xmlns:a="http://schemas.openxmlformats.org/drawingml/2006/main" xmlns:r="http://schemas.openxmlformats.org/officeDocument/2006/relationships" xmlns:p="http://schemas.openxmlformats.org/presentationml/2006/main">
   <p:cSld>
     <p:spTree>
       <p:nvGrpSpPr>
@@ -7856,7 +8166,14 @@
         <p:cNvGrpSpPr/>
         <p:nvPr/>
       </p:nvGrpSpPr>
-      <p:grpSpPr/>
+      <p:grpSpPr>
+        <a:xfrm>
+          <a:off x="0" y="0"/>
+          <a:ext cx="0" cy="0"/>
+          <a:chOff x="0" y="0"/>
+          <a:chExt cx="0" cy="0"/>
+        </a:xfrm>
+      </p:grpSpPr>
       <p:sp>
         <p:nvSpPr>
           <p:cNvPr id="2" name="Rectangle 1"/>
@@ -7893,7 +8210,7 @@
           </a:fontRef>
         </p:style>
         <p:txBody>
-          <a:bodyPr rtlCol="0" anchor="ctr" wrap="square"/>
+          <a:bodyPr wrap="square" rtlCol="0" anchor="ctr"/>
           <a:lstStyle/>
           <a:p>
             <a:pPr algn="l">
@@ -8058,6 +8375,7 @@
           <a:lstStyle/>
           <a:p>
             <a:pPr algn="ctr"/>
+            <a:endParaRPr/>
           </a:p>
         </p:txBody>
       </p:sp>
@@ -8101,6 +8419,7 @@
           <a:lstStyle/>
           <a:p>
             <a:pPr algn="ctr"/>
+            <a:endParaRPr/>
           </a:p>
         </p:txBody>
       </p:sp>
@@ -8121,7 +8440,7 @@
           <a:noFill/>
         </p:spPr>
         <p:txBody>
-          <a:bodyPr wrap="square" a:anchor="ctr"/>
+          <a:bodyPr wrap="square"/>
           <a:lstStyle/>
           <a:p>
             <a:pPr>
@@ -8147,7 +8466,7 @@
 </file>
 
 <file path=ppt/slides/slide4.xml><?xml version="1.0" encoding="utf-8"?>
-<p:sld xmlns:a="http://schemas.openxmlformats.org/drawingml/2006/main" xmlns:p="http://schemas.openxmlformats.org/presentationml/2006/main" xmlns:r="http://schemas.openxmlformats.org/officeDocument/2006/relationships">
+<p:sld xmlns:a="http://schemas.openxmlformats.org/drawingml/2006/main" xmlns:r="http://schemas.openxmlformats.org/officeDocument/2006/relationships" xmlns:p="http://schemas.openxmlformats.org/presentationml/2006/main">
   <p:cSld>
     <p:spTree>
       <p:nvGrpSpPr>
@@ -8155,7 +8474,14 @@
         <p:cNvGrpSpPr/>
         <p:nvPr/>
       </p:nvGrpSpPr>
-      <p:grpSpPr/>
+      <p:grpSpPr>
+        <a:xfrm>
+          <a:off x="0" y="0"/>
+          <a:ext cx="0" cy="0"/>
+          <a:chOff x="0" y="0"/>
+          <a:chExt cx="0" cy="0"/>
+        </a:xfrm>
+      </p:grpSpPr>
       <p:sp>
         <p:nvSpPr>
           <p:cNvPr id="2" name="Rectangle 1"/>
@@ -8192,7 +8518,7 @@
           </a:fontRef>
         </p:style>
         <p:txBody>
-          <a:bodyPr rtlCol="0" anchor="ctr" wrap="square"/>
+          <a:bodyPr wrap="square" rtlCol="0" anchor="ctr"/>
           <a:lstStyle/>
           <a:p>
             <a:pPr algn="l">
@@ -8333,6 +8659,7 @@
           <a:lstStyle/>
           <a:p>
             <a:pPr algn="ctr"/>
+            <a:endParaRPr/>
           </a:p>
         </p:txBody>
       </p:sp>
@@ -8376,6 +8703,7 @@
           <a:lstStyle/>
           <a:p>
             <a:pPr algn="ctr"/>
+            <a:endParaRPr/>
           </a:p>
         </p:txBody>
       </p:sp>
@@ -8396,11 +8724,11 @@
           <a:noFill/>
         </p:spPr>
         <p:txBody>
-          <a:bodyPr wrap="square" a:anchor="ctr"/>
+          <a:bodyPr wrap="square"/>
           <a:lstStyle/>
           <a:p>
             <a:r>
-              <a:rPr b="1" sz="1100">
+              <a:rPr sz="1100" b="1">
                 <a:solidFill>
                   <a:srgbClr val="29065A"/>
                 </a:solidFill>
@@ -8463,8 +8791,20 @@
                 <a:tableStyleId>{5C22544A-7EE6-4342-B048-85BDC9FD1C3A}</a:tableStyleId>
               </a:tblPr>
               <a:tblGrid>
-                <a:gridCol w="4763288"/>
-                <a:gridCol w="5596863"/>
+                <a:gridCol w="4763288">
+                  <a:extLst>
+                    <a:ext uri="{9D8B030D-6E8A-4147-A177-3AD203B41FA5}">
+                      <a16:colId xmlns:a16="http://schemas.microsoft.com/office/drawing/2014/main" val="20000"/>
+                    </a:ext>
+                  </a:extLst>
+                </a:gridCol>
+                <a:gridCol w="5596863">
+                  <a:extLst>
+                    <a:ext uri="{9D8B030D-6E8A-4147-A177-3AD203B41FA5}">
+                      <a16:colId xmlns:a16="http://schemas.microsoft.com/office/drawing/2014/main" val="20001"/>
+                    </a:ext>
+                  </a:extLst>
+                </a:gridCol>
               </a:tblGrid>
               <a:tr h="320040">
                 <a:tc>
@@ -8515,6 +8855,11 @@
                     </a:solidFill>
                   </a:tcPr>
                 </a:tc>
+                <a:extLst>
+                  <a:ext uri="{0D108BD9-81ED-4DB2-BD59-A6C34878D82A}">
+                    <a16:rowId xmlns:a16="http://schemas.microsoft.com/office/drawing/2014/main" val="10000"/>
+                  </a:ext>
+                </a:extLst>
               </a:tr>
               <a:tr h="320040">
                 <a:tc>
@@ -8557,6 +8902,11 @@
                   </a:txBody>
                   <a:tcPr anchor="ctr"/>
                 </a:tc>
+                <a:extLst>
+                  <a:ext uri="{0D108BD9-81ED-4DB2-BD59-A6C34878D82A}">
+                    <a16:rowId xmlns:a16="http://schemas.microsoft.com/office/drawing/2014/main" val="10001"/>
+                  </a:ext>
+                </a:extLst>
               </a:tr>
               <a:tr h="320040">
                 <a:tc>
@@ -8607,6 +8957,11 @@
                     </a:solidFill>
                   </a:tcPr>
                 </a:tc>
+                <a:extLst>
+                  <a:ext uri="{0D108BD9-81ED-4DB2-BD59-A6C34878D82A}">
+                    <a16:rowId xmlns:a16="http://schemas.microsoft.com/office/drawing/2014/main" val="10002"/>
+                  </a:ext>
+                </a:extLst>
               </a:tr>
               <a:tr h="320040">
                 <a:tc>
@@ -8649,6 +9004,11 @@
                   </a:txBody>
                   <a:tcPr anchor="ctr"/>
                 </a:tc>
+                <a:extLst>
+                  <a:ext uri="{0D108BD9-81ED-4DB2-BD59-A6C34878D82A}">
+                    <a16:rowId xmlns:a16="http://schemas.microsoft.com/office/drawing/2014/main" val="10003"/>
+                  </a:ext>
+                </a:extLst>
               </a:tr>
               <a:tr h="320040">
                 <a:tc>
@@ -8699,6 +9059,11 @@
                     </a:solidFill>
                   </a:tcPr>
                 </a:tc>
+                <a:extLst>
+                  <a:ext uri="{0D108BD9-81ED-4DB2-BD59-A6C34878D82A}">
+                    <a16:rowId xmlns:a16="http://schemas.microsoft.com/office/drawing/2014/main" val="10004"/>
+                  </a:ext>
+                </a:extLst>
               </a:tr>
             </a:tbl>
           </a:graphicData>
@@ -8713,7 +9078,7 @@
 </file>
 
 <file path=ppt/slides/slide5.xml><?xml version="1.0" encoding="utf-8"?>
-<p:sld xmlns:a="http://schemas.openxmlformats.org/drawingml/2006/main" xmlns:p="http://schemas.openxmlformats.org/presentationml/2006/main" xmlns:r="http://schemas.openxmlformats.org/officeDocument/2006/relationships">
+<p:sld xmlns:a="http://schemas.openxmlformats.org/drawingml/2006/main" xmlns:r="http://schemas.openxmlformats.org/officeDocument/2006/relationships" xmlns:p="http://schemas.openxmlformats.org/presentationml/2006/main">
   <p:cSld>
     <p:spTree>
       <p:nvGrpSpPr>
@@ -8721,7 +9086,14 @@
         <p:cNvGrpSpPr/>
         <p:nvPr/>
       </p:nvGrpSpPr>
-      <p:grpSpPr/>
+      <p:grpSpPr>
+        <a:xfrm>
+          <a:off x="0" y="0"/>
+          <a:ext cx="0" cy="0"/>
+          <a:chOff x="0" y="0"/>
+          <a:chExt cx="0" cy="0"/>
+        </a:xfrm>
+      </p:grpSpPr>
       <p:sp>
         <p:nvSpPr>
           <p:cNvPr id="2" name="Rectangle 1"/>
@@ -8758,7 +9130,7 @@
           </a:fontRef>
         </p:style>
         <p:txBody>
-          <a:bodyPr rtlCol="0" anchor="ctr" wrap="square"/>
+          <a:bodyPr wrap="square" rtlCol="0" anchor="ctr"/>
           <a:lstStyle/>
           <a:p>
             <a:pPr algn="l">
@@ -8923,6 +9295,7 @@
           <a:lstStyle/>
           <a:p>
             <a:pPr algn="ctr"/>
+            <a:endParaRPr/>
           </a:p>
         </p:txBody>
       </p:sp>
@@ -8966,6 +9339,7 @@
           <a:lstStyle/>
           <a:p>
             <a:pPr algn="ctr"/>
+            <a:endParaRPr/>
           </a:p>
         </p:txBody>
       </p:sp>
@@ -8986,7 +9360,7 @@
           <a:noFill/>
         </p:spPr>
         <p:txBody>
-          <a:bodyPr wrap="square" a:anchor="ctr"/>
+          <a:bodyPr wrap="square"/>
           <a:lstStyle/>
           <a:p>
             <a:pPr>
@@ -9012,7 +9386,7 @@
 </file>
 
 <file path=ppt/slides/slide6.xml><?xml version="1.0" encoding="utf-8"?>
-<p:sld xmlns:a="http://schemas.openxmlformats.org/drawingml/2006/main" xmlns:p="http://schemas.openxmlformats.org/presentationml/2006/main" xmlns:r="http://schemas.openxmlformats.org/officeDocument/2006/relationships">
+<p:sld xmlns:a="http://schemas.openxmlformats.org/drawingml/2006/main" xmlns:r="http://schemas.openxmlformats.org/officeDocument/2006/relationships" xmlns:p="http://schemas.openxmlformats.org/presentationml/2006/main">
   <p:cSld>
     <p:spTree>
       <p:nvGrpSpPr>
@@ -9020,7 +9394,14 @@
         <p:cNvGrpSpPr/>
         <p:nvPr/>
       </p:nvGrpSpPr>
-      <p:grpSpPr/>
+      <p:grpSpPr>
+        <a:xfrm>
+          <a:off x="0" y="0"/>
+          <a:ext cx="0" cy="0"/>
+          <a:chOff x="0" y="0"/>
+          <a:chExt cx="0" cy="0"/>
+        </a:xfrm>
+      </p:grpSpPr>
       <p:sp>
         <p:nvSpPr>
           <p:cNvPr id="2" name="Rectangle 1"/>
@@ -9057,7 +9438,7 @@
           </a:fontRef>
         </p:style>
         <p:txBody>
-          <a:bodyPr rtlCol="0" anchor="ctr" wrap="square"/>
+          <a:bodyPr wrap="square" rtlCol="0" anchor="ctr"/>
           <a:lstStyle/>
           <a:p>
             <a:pPr algn="l">
@@ -9191,7 +9572,7 @@
 </file>
 
 <file path=ppt/slides/slide7.xml><?xml version="1.0" encoding="utf-8"?>
-<p:sld xmlns:a="http://schemas.openxmlformats.org/drawingml/2006/main" xmlns:p="http://schemas.openxmlformats.org/presentationml/2006/main" xmlns:r="http://schemas.openxmlformats.org/officeDocument/2006/relationships">
+<p:sld xmlns:a="http://schemas.openxmlformats.org/drawingml/2006/main" xmlns:r="http://schemas.openxmlformats.org/officeDocument/2006/relationships" xmlns:p="http://schemas.openxmlformats.org/presentationml/2006/main">
   <p:cSld>
     <p:spTree>
       <p:nvGrpSpPr>
@@ -9199,7 +9580,14 @@
         <p:cNvGrpSpPr/>
         <p:nvPr/>
       </p:nvGrpSpPr>
-      <p:grpSpPr/>
+      <p:grpSpPr>
+        <a:xfrm>
+          <a:off x="0" y="0"/>
+          <a:ext cx="0" cy="0"/>
+          <a:chOff x="0" y="0"/>
+          <a:chExt cx="0" cy="0"/>
+        </a:xfrm>
+      </p:grpSpPr>
       <p:sp>
         <p:nvSpPr>
           <p:cNvPr id="2" name="Rectangle 1"/>
@@ -9236,7 +9624,7 @@
           </a:fontRef>
         </p:style>
         <p:txBody>
-          <a:bodyPr rtlCol="0" anchor="ctr" wrap="square"/>
+          <a:bodyPr wrap="square" rtlCol="0" anchor="ctr"/>
           <a:lstStyle/>
           <a:p>
             <a:pPr algn="l">
@@ -9356,9 +9744,27 @@
                 <a:tableStyleId>{5C22544A-7EE6-4342-B048-85BDC9FD1C3A}</a:tableStyleId>
               </a:tblPr>
               <a:tblGrid>
-                <a:gridCol w="3278529"/>
-                <a:gridCol w="3934234"/>
-                <a:gridCol w="3147387"/>
+                <a:gridCol w="3278529">
+                  <a:extLst>
+                    <a:ext uri="{9D8B030D-6E8A-4147-A177-3AD203B41FA5}">
+                      <a16:colId xmlns:a16="http://schemas.microsoft.com/office/drawing/2014/main" val="20000"/>
+                    </a:ext>
+                  </a:extLst>
+                </a:gridCol>
+                <a:gridCol w="3934234">
+                  <a:extLst>
+                    <a:ext uri="{9D8B030D-6E8A-4147-A177-3AD203B41FA5}">
+                      <a16:colId xmlns:a16="http://schemas.microsoft.com/office/drawing/2014/main" val="20001"/>
+                    </a:ext>
+                  </a:extLst>
+                </a:gridCol>
+                <a:gridCol w="3147387">
+                  <a:extLst>
+                    <a:ext uri="{9D8B030D-6E8A-4147-A177-3AD203B41FA5}">
+                      <a16:colId xmlns:a16="http://schemas.microsoft.com/office/drawing/2014/main" val="20002"/>
+                    </a:ext>
+                  </a:extLst>
+                </a:gridCol>
               </a:tblGrid>
               <a:tr h="320040">
                 <a:tc>
@@ -9433,6 +9839,11 @@
                     </a:solidFill>
                   </a:tcPr>
                 </a:tc>
+                <a:extLst>
+                  <a:ext uri="{0D108BD9-81ED-4DB2-BD59-A6C34878D82A}">
+                    <a16:rowId xmlns:a16="http://schemas.microsoft.com/office/drawing/2014/main" val="10000"/>
+                  </a:ext>
+                </a:extLst>
               </a:tr>
               <a:tr h="320040">
                 <a:tc>
@@ -9495,6 +9906,11 @@
                   </a:txBody>
                   <a:tcPr anchor="ctr"/>
                 </a:tc>
+                <a:extLst>
+                  <a:ext uri="{0D108BD9-81ED-4DB2-BD59-A6C34878D82A}">
+                    <a16:rowId xmlns:a16="http://schemas.microsoft.com/office/drawing/2014/main" val="10001"/>
+                  </a:ext>
+                </a:extLst>
               </a:tr>
               <a:tr h="320040">
                 <a:tc>
@@ -9569,6 +9985,11 @@
                     </a:solidFill>
                   </a:tcPr>
                 </a:tc>
+                <a:extLst>
+                  <a:ext uri="{0D108BD9-81ED-4DB2-BD59-A6C34878D82A}">
+                    <a16:rowId xmlns:a16="http://schemas.microsoft.com/office/drawing/2014/main" val="10002"/>
+                  </a:ext>
+                </a:extLst>
               </a:tr>
               <a:tr h="320040">
                 <a:tc>
@@ -9631,6 +10052,11 @@
                   </a:txBody>
                   <a:tcPr anchor="ctr"/>
                 </a:tc>
+                <a:extLst>
+                  <a:ext uri="{0D108BD9-81ED-4DB2-BD59-A6C34878D82A}">
+                    <a16:rowId xmlns:a16="http://schemas.microsoft.com/office/drawing/2014/main" val="10003"/>
+                  </a:ext>
+                </a:extLst>
               </a:tr>
               <a:tr h="320040">
                 <a:tc>
@@ -9705,6 +10131,11 @@
                     </a:solidFill>
                   </a:tcPr>
                 </a:tc>
+                <a:extLst>
+                  <a:ext uri="{0D108BD9-81ED-4DB2-BD59-A6C34878D82A}">
+                    <a16:rowId xmlns:a16="http://schemas.microsoft.com/office/drawing/2014/main" val="10004"/>
+                  </a:ext>
+                </a:extLst>
               </a:tr>
               <a:tr h="320040">
                 <a:tc>
@@ -9767,6 +10198,11 @@
                   </a:txBody>
                   <a:tcPr anchor="ctr"/>
                 </a:tc>
+                <a:extLst>
+                  <a:ext uri="{0D108BD9-81ED-4DB2-BD59-A6C34878D82A}">
+                    <a16:rowId xmlns:a16="http://schemas.microsoft.com/office/drawing/2014/main" val="10005"/>
+                  </a:ext>
+                </a:extLst>
               </a:tr>
               <a:tr h="320040">
                 <a:tc>
@@ -9841,6 +10277,11 @@
                     </a:solidFill>
                   </a:tcPr>
                 </a:tc>
+                <a:extLst>
+                  <a:ext uri="{0D108BD9-81ED-4DB2-BD59-A6C34878D82A}">
+                    <a16:rowId xmlns:a16="http://schemas.microsoft.com/office/drawing/2014/main" val="10006"/>
+                  </a:ext>
+                </a:extLst>
               </a:tr>
               <a:tr h="320040">
                 <a:tc>
@@ -9903,6 +10344,11 @@
                   </a:txBody>
                   <a:tcPr anchor="ctr"/>
                 </a:tc>
+                <a:extLst>
+                  <a:ext uri="{0D108BD9-81ED-4DB2-BD59-A6C34878D82A}">
+                    <a16:rowId xmlns:a16="http://schemas.microsoft.com/office/drawing/2014/main" val="10007"/>
+                  </a:ext>
+                </a:extLst>
               </a:tr>
               <a:tr h="320040">
                 <a:tc>
@@ -9977,6 +10423,11 @@
                     </a:solidFill>
                   </a:tcPr>
                 </a:tc>
+                <a:extLst>
+                  <a:ext uri="{0D108BD9-81ED-4DB2-BD59-A6C34878D82A}">
+                    <a16:rowId xmlns:a16="http://schemas.microsoft.com/office/drawing/2014/main" val="10008"/>
+                  </a:ext>
+                </a:extLst>
               </a:tr>
               <a:tr h="320040">
                 <a:tc>
@@ -10039,6 +10490,11 @@
                   </a:txBody>
                   <a:tcPr anchor="ctr"/>
                 </a:tc>
+                <a:extLst>
+                  <a:ext uri="{0D108BD9-81ED-4DB2-BD59-A6C34878D82A}">
+                    <a16:rowId xmlns:a16="http://schemas.microsoft.com/office/drawing/2014/main" val="10009"/>
+                  </a:ext>
+                </a:extLst>
               </a:tr>
               <a:tr h="320040">
                 <a:tc>
@@ -10113,6 +10569,11 @@
                     </a:solidFill>
                   </a:tcPr>
                 </a:tc>
+                <a:extLst>
+                  <a:ext uri="{0D108BD9-81ED-4DB2-BD59-A6C34878D82A}">
+                    <a16:rowId xmlns:a16="http://schemas.microsoft.com/office/drawing/2014/main" val="10010"/>
+                  </a:ext>
+                </a:extLst>
               </a:tr>
             </a:tbl>
           </a:graphicData>
@@ -10127,7 +10588,7 @@
 </file>
 
 <file path=ppt/slides/slide8.xml><?xml version="1.0" encoding="utf-8"?>
-<p:sld xmlns:a="http://schemas.openxmlformats.org/drawingml/2006/main" xmlns:p="http://schemas.openxmlformats.org/presentationml/2006/main" xmlns:r="http://schemas.openxmlformats.org/officeDocument/2006/relationships">
+<p:sld xmlns:a="http://schemas.openxmlformats.org/drawingml/2006/main" xmlns:r="http://schemas.openxmlformats.org/officeDocument/2006/relationships" xmlns:p="http://schemas.openxmlformats.org/presentationml/2006/main">
   <p:cSld>
     <p:spTree>
       <p:nvGrpSpPr>
@@ -10135,7 +10596,14 @@
         <p:cNvGrpSpPr/>
         <p:nvPr/>
       </p:nvGrpSpPr>
-      <p:grpSpPr/>
+      <p:grpSpPr>
+        <a:xfrm>
+          <a:off x="0" y="0"/>
+          <a:ext cx="0" cy="0"/>
+          <a:chOff x="0" y="0"/>
+          <a:chExt cx="0" cy="0"/>
+        </a:xfrm>
+      </p:grpSpPr>
       <p:sp>
         <p:nvSpPr>
           <p:cNvPr id="2" name="Rectangle 1"/>
@@ -10172,7 +10640,7 @@
           </a:fontRef>
         </p:style>
         <p:txBody>
-          <a:bodyPr rtlCol="0" anchor="ctr" wrap="square"/>
+          <a:bodyPr wrap="square" rtlCol="0" anchor="ctr"/>
           <a:lstStyle/>
           <a:p>
             <a:pPr algn="l">
@@ -10338,7 +10806,7 @@
 </file>
 
 <file path=ppt/slides/slide9.xml><?xml version="1.0" encoding="utf-8"?>
-<p:sld xmlns:a="http://schemas.openxmlformats.org/drawingml/2006/main" xmlns:p="http://schemas.openxmlformats.org/presentationml/2006/main" xmlns:r="http://schemas.openxmlformats.org/officeDocument/2006/relationships">
+<p:sld xmlns:a="http://schemas.openxmlformats.org/drawingml/2006/main" xmlns:r="http://schemas.openxmlformats.org/officeDocument/2006/relationships" xmlns:p="http://schemas.openxmlformats.org/presentationml/2006/main">
   <p:cSld>
     <p:spTree>
       <p:nvGrpSpPr>
@@ -10346,7 +10814,14 @@
         <p:cNvGrpSpPr/>
         <p:nvPr/>
       </p:nvGrpSpPr>
-      <p:grpSpPr/>
+      <p:grpSpPr>
+        <a:xfrm>
+          <a:off x="0" y="0"/>
+          <a:ext cx="0" cy="0"/>
+          <a:chOff x="0" y="0"/>
+          <a:chExt cx="0" cy="0"/>
+        </a:xfrm>
+      </p:grpSpPr>
       <p:sp>
         <p:nvSpPr>
           <p:cNvPr id="2" name="Rectangle 1"/>
@@ -10383,7 +10858,7 @@
           </a:fontRef>
         </p:style>
         <p:txBody>
-          <a:bodyPr rtlCol="0" anchor="ctr" wrap="square"/>
+          <a:bodyPr wrap="square" rtlCol="0" anchor="ctr"/>
           <a:lstStyle/>
           <a:p>
             <a:pPr algn="l">
@@ -10494,7 +10969,7 @@
         </p:nvGraphicFramePr>
         <p:xfrm>
           <a:off x="914400" y="960120"/>
-          <a:ext cx="10360150" cy="1280160"/>
+          <a:ext cx="10519096" cy="1325880"/>
         </p:xfrm>
         <a:graphic>
           <a:graphicData uri="http://schemas.openxmlformats.org/drawingml/2006/table">
@@ -10503,10 +10978,34 @@
                 <a:tableStyleId>{5C22544A-7EE6-4342-B048-85BDC9FD1C3A}</a:tableStyleId>
               </a:tblPr>
               <a:tblGrid>
-                <a:gridCol w="49334"/>
-                <a:gridCol w="1924028"/>
-                <a:gridCol w="4144060"/>
-                <a:gridCol w="4242728"/>
+                <a:gridCol w="208280">
+                  <a:extLst>
+                    <a:ext uri="{9D8B030D-6E8A-4147-A177-3AD203B41FA5}">
+                      <a16:colId xmlns:a16="http://schemas.microsoft.com/office/drawing/2014/main" val="20000"/>
+                    </a:ext>
+                  </a:extLst>
+                </a:gridCol>
+                <a:gridCol w="1924028">
+                  <a:extLst>
+                    <a:ext uri="{9D8B030D-6E8A-4147-A177-3AD203B41FA5}">
+                      <a16:colId xmlns:a16="http://schemas.microsoft.com/office/drawing/2014/main" val="20001"/>
+                    </a:ext>
+                  </a:extLst>
+                </a:gridCol>
+                <a:gridCol w="4144060">
+                  <a:extLst>
+                    <a:ext uri="{9D8B030D-6E8A-4147-A177-3AD203B41FA5}">
+                      <a16:colId xmlns:a16="http://schemas.microsoft.com/office/drawing/2014/main" val="20002"/>
+                    </a:ext>
+                  </a:extLst>
+                </a:gridCol>
+                <a:gridCol w="4242728">
+                  <a:extLst>
+                    <a:ext uri="{9D8B030D-6E8A-4147-A177-3AD203B41FA5}">
+                      <a16:colId xmlns:a16="http://schemas.microsoft.com/office/drawing/2014/main" val="20003"/>
+                    </a:ext>
+                  </a:extLst>
+                </a:gridCol>
               </a:tblGrid>
               <a:tr h="320040">
                 <a:tc>
@@ -10605,6 +11104,11 @@
                     </a:solidFill>
                   </a:tcPr>
                 </a:tc>
+                <a:extLst>
+                  <a:ext uri="{0D108BD9-81ED-4DB2-BD59-A6C34878D82A}">
+                    <a16:rowId xmlns:a16="http://schemas.microsoft.com/office/drawing/2014/main" val="10000"/>
+                  </a:ext>
+                </a:extLst>
               </a:tr>
               <a:tr h="320040">
                 <a:tc>
@@ -10687,6 +11191,11 @@
                   </a:txBody>
                   <a:tcPr anchor="ctr"/>
                 </a:tc>
+                <a:extLst>
+                  <a:ext uri="{0D108BD9-81ED-4DB2-BD59-A6C34878D82A}">
+                    <a16:rowId xmlns:a16="http://schemas.microsoft.com/office/drawing/2014/main" val="10001"/>
+                  </a:ext>
+                </a:extLst>
               </a:tr>
               <a:tr h="320040">
                 <a:tc>
@@ -10785,6 +11294,11 @@
                     </a:solidFill>
                   </a:tcPr>
                 </a:tc>
+                <a:extLst>
+                  <a:ext uri="{0D108BD9-81ED-4DB2-BD59-A6C34878D82A}">
+                    <a16:rowId xmlns:a16="http://schemas.microsoft.com/office/drawing/2014/main" val="10002"/>
+                  </a:ext>
+                </a:extLst>
               </a:tr>
               <a:tr h="320040">
                 <a:tc>
@@ -10867,6 +11381,11 @@
                   </a:txBody>
                   <a:tcPr anchor="ctr"/>
                 </a:tc>
+                <a:extLst>
+                  <a:ext uri="{0D108BD9-81ED-4DB2-BD59-A6C34878D82A}">
+                    <a16:rowId xmlns:a16="http://schemas.microsoft.com/office/drawing/2014/main" val="10003"/>
+                  </a:ext>
+                </a:extLst>
               </a:tr>
             </a:tbl>
           </a:graphicData>
@@ -10912,6 +11431,7 @@
           <a:lstStyle/>
           <a:p>
             <a:pPr algn="ctr"/>
+            <a:endParaRPr/>
           </a:p>
         </p:txBody>
       </p:sp>
@@ -10955,6 +11475,7 @@
           <a:lstStyle/>
           <a:p>
             <a:pPr algn="ctr"/>
+            <a:endParaRPr/>
           </a:p>
         </p:txBody>
       </p:sp>
@@ -10975,11 +11496,11 @@
           <a:noFill/>
         </p:spPr>
         <p:txBody>
-          <a:bodyPr wrap="square" a:anchor="ctr"/>
+          <a:bodyPr wrap="square"/>
           <a:lstStyle/>
           <a:p>
             <a:r>
-              <a:rPr b="1" sz="1100">
+              <a:rPr sz="1100" b="1">
                 <a:solidFill>
                   <a:srgbClr val="29065A"/>
                 </a:solidFill>

</xml_diff>